<commit_message>
docs: change SHOT F1 from 0.8546 to 0.8545 (updated results, generated tables, PDF and slides)
</commit_message>
<xml_diff>
--- a/publications/thesis/releases/AutoShotV2_Defense.pptx
+++ b/publications/thesis/releases/AutoShotV2_Defense.pptx
@@ -18371,7 +18371,7 @@
         <p:spPr>
           <a:xfrm>
             <a:off x="7955280" y="3840480"/>
-            <a:ext cx="2544349" cy="457200"/>
+            <a:ext cx="2542946" cy="457200"/>
           </a:xfrm>
           <a:prstGeom prst="rect">
             <a:avLst/>
@@ -18414,7 +18414,7 @@
         </p:nvSpPr>
         <p:spPr>
           <a:xfrm>
-            <a:off x="10591069" y="3950208"/>
+            <a:off x="10589666" y="3950208"/>
             <a:ext cx="731520" cy="457200"/>
           </a:xfrm>
           <a:prstGeom prst="rect">

</xml_diff>